<commit_message>
Update Executive Presentation 2026
</commit_message>
<xml_diff>
--- a/Sachin_Bagul_Executive_Presentation_2026.pptx
+++ b/Sachin_Bagul_Executive_Presentation_2026.pptx
@@ -299,7 +299,7 @@
           <a:p>
             <a:fld id="{5BCAD085-E8A6-8845-BD4E-CB4CCA059FC4}" type="datetimeFigureOut">
               <a:rPr lang="en-US" smtClean="0"/>
-              <a:t>9/2/2026</a:t>
+              <a:t>9/4/2026</a:t>
             </a:fld>
             <a:endParaRPr lang="en-US"/>
           </a:p>
@@ -469,7 +469,7 @@
           <a:p>
             <a:fld id="{5BCAD085-E8A6-8845-BD4E-CB4CCA059FC4}" type="datetimeFigureOut">
               <a:rPr lang="en-US" smtClean="0"/>
-              <a:t>9/2/2026</a:t>
+              <a:t>9/4/2026</a:t>
             </a:fld>
             <a:endParaRPr lang="en-US"/>
           </a:p>
@@ -649,7 +649,7 @@
           <a:p>
             <a:fld id="{5BCAD085-E8A6-8845-BD4E-CB4CCA059FC4}" type="datetimeFigureOut">
               <a:rPr lang="en-US" smtClean="0"/>
-              <a:t>9/2/2026</a:t>
+              <a:t>9/4/2026</a:t>
             </a:fld>
             <a:endParaRPr lang="en-US"/>
           </a:p>
@@ -819,7 +819,7 @@
           <a:p>
             <a:fld id="{5BCAD085-E8A6-8845-BD4E-CB4CCA059FC4}" type="datetimeFigureOut">
               <a:rPr lang="en-US" smtClean="0"/>
-              <a:t>9/2/2026</a:t>
+              <a:t>9/4/2026</a:t>
             </a:fld>
             <a:endParaRPr lang="en-US"/>
           </a:p>
@@ -1065,7 +1065,7 @@
           <a:p>
             <a:fld id="{5BCAD085-E8A6-8845-BD4E-CB4CCA059FC4}" type="datetimeFigureOut">
               <a:rPr lang="en-US" smtClean="0"/>
-              <a:t>9/2/2026</a:t>
+              <a:t>9/4/2026</a:t>
             </a:fld>
             <a:endParaRPr lang="en-US"/>
           </a:p>
@@ -1353,7 +1353,7 @@
           <a:p>
             <a:fld id="{5BCAD085-E8A6-8845-BD4E-CB4CCA059FC4}" type="datetimeFigureOut">
               <a:rPr lang="en-US" smtClean="0"/>
-              <a:t>9/2/2026</a:t>
+              <a:t>9/4/2026</a:t>
             </a:fld>
             <a:endParaRPr lang="en-US"/>
           </a:p>
@@ -1775,7 +1775,7 @@
           <a:p>
             <a:fld id="{5BCAD085-E8A6-8845-BD4E-CB4CCA059FC4}" type="datetimeFigureOut">
               <a:rPr lang="en-US" smtClean="0"/>
-              <a:t>9/2/2026</a:t>
+              <a:t>9/4/2026</a:t>
             </a:fld>
             <a:endParaRPr lang="en-US"/>
           </a:p>
@@ -1893,7 +1893,7 @@
           <a:p>
             <a:fld id="{5BCAD085-E8A6-8845-BD4E-CB4CCA059FC4}" type="datetimeFigureOut">
               <a:rPr lang="en-US" smtClean="0"/>
-              <a:t>9/2/2026</a:t>
+              <a:t>9/4/2026</a:t>
             </a:fld>
             <a:endParaRPr lang="en-US"/>
           </a:p>
@@ -1988,7 +1988,7 @@
           <a:p>
             <a:fld id="{5BCAD085-E8A6-8845-BD4E-CB4CCA059FC4}" type="datetimeFigureOut">
               <a:rPr lang="en-US" smtClean="0"/>
-              <a:t>9/2/2026</a:t>
+              <a:t>9/4/2026</a:t>
             </a:fld>
             <a:endParaRPr lang="en-US"/>
           </a:p>
@@ -2265,7 +2265,7 @@
           <a:p>
             <a:fld id="{5BCAD085-E8A6-8845-BD4E-CB4CCA059FC4}" type="datetimeFigureOut">
               <a:rPr lang="en-US" smtClean="0"/>
-              <a:t>9/2/2026</a:t>
+              <a:t>9/4/2026</a:t>
             </a:fld>
             <a:endParaRPr lang="en-US"/>
           </a:p>
@@ -2518,7 +2518,7 @@
           <a:p>
             <a:fld id="{5BCAD085-E8A6-8845-BD4E-CB4CCA059FC4}" type="datetimeFigureOut">
               <a:rPr lang="en-US" smtClean="0"/>
-              <a:t>9/2/2026</a:t>
+              <a:t>9/4/2026</a:t>
             </a:fld>
             <a:endParaRPr lang="en-US"/>
           </a:p>
@@ -2731,7 +2731,7 @@
           <a:p>
             <a:fld id="{5BCAD085-E8A6-8845-BD4E-CB4CCA059FC4}" type="datetimeFigureOut">
               <a:rPr lang="en-US" smtClean="0"/>
-              <a:t>9/2/2026</a:t>
+              <a:t>9/4/2026</a:t>
             </a:fld>
             <a:endParaRPr lang="en-US"/>
           </a:p>
@@ -3835,7 +3835,25 @@
                 </a:solidFill>
                 <a:latin typeface="Aptos"/>
               </a:rPr>
-              <a:t>TWO COMPLEMENTARY EXECUTIVE PROFILES</a:t>
+              <a:t>TWO </a:t>
+            </a:r>
+            <a:r>
+              <a:rPr sz="1500" b="1" dirty="0" smtClean="0">
+                <a:solidFill>
+                  <a:srgbClr val="FFFFFF"/>
+                </a:solidFill>
+                <a:latin typeface="Aptos"/>
+              </a:rPr>
+              <a:t>COMPLEMENTARY EXECUTIVE </a:t>
+            </a:r>
+            <a:r>
+              <a:rPr sz="1500" b="1" dirty="0">
+                <a:solidFill>
+                  <a:srgbClr val="FFFFFF"/>
+                </a:solidFill>
+                <a:latin typeface="Aptos"/>
+              </a:rPr>
+              <a:t>PROFILES</a:t>
             </a:r>
           </a:p>
         </p:txBody>
@@ -7363,18 +7381,7 @@
                 </a:solidFill>
                 <a:latin typeface="Aptos"/>
               </a:rPr>
-              <a:t> Leader , Casting &amp; Machinin</a:t>
-            </a:r>
-            <a:r>
-              <a:rPr lang="en-US" sz="800" b="1" dirty="0" smtClean="0">
-                <a:solidFill>
-                  <a:schemeClr val="accent6">
-                    <a:lumMod val="50000"/>
-                  </a:schemeClr>
-                </a:solidFill>
-                <a:latin typeface="Aptos"/>
-              </a:rPr>
-              <a:t>g Commodity </a:t>
+              <a:t> Leader , Casting &amp; Machining Commodity </a:t>
             </a:r>
             <a:endParaRPr sz="800" b="1" dirty="0">
               <a:solidFill>
@@ -10820,7 +10827,7 @@
         <p:spPr>
           <a:xfrm>
             <a:off x="6217920" y="1737360"/>
-            <a:ext cx="5074920" cy="4023360"/>
+            <a:ext cx="5074920" cy="1118255"/>
           </a:xfrm>
           <a:prstGeom prst="rect">
             <a:avLst/>
@@ -10845,7 +10852,20 @@
               </a:defRPr>
             </a:pPr>
             <a:r>
-              <a:t>• $300M+ global procurement spend</a:t>
+              <a:rPr dirty="0"/>
+              <a:t>• </a:t>
+            </a:r>
+            <a:r>
+              <a:rPr lang="en-US" dirty="0" smtClean="0"/>
+              <a:t>G</a:t>
+            </a:r>
+            <a:r>
+              <a:rPr dirty="0" smtClean="0"/>
+              <a:t>lobal </a:t>
+            </a:r>
+            <a:r>
+              <a:rPr dirty="0"/>
+              <a:t>procurement spend</a:t>
             </a:r>
           </a:p>
           <a:p>
@@ -10861,7 +10881,24 @@
               </a:defRPr>
             </a:pPr>
             <a:r>
-              <a:t>• 5%+ YoY MATEX savings responsibility</a:t>
+              <a:rPr dirty="0"/>
+              <a:t>• </a:t>
+            </a:r>
+            <a:r>
+              <a:rPr lang="en-US" dirty="0"/>
+              <a:t> </a:t>
+            </a:r>
+            <a:r>
+              <a:rPr dirty="0" err="1" smtClean="0"/>
+              <a:t>YoY</a:t>
+            </a:r>
+            <a:r>
+              <a:rPr dirty="0" smtClean="0"/>
+              <a:t> </a:t>
+            </a:r>
+            <a:r>
+              <a:rPr dirty="0"/>
+              <a:t>MATEX savings responsibility</a:t>
             </a:r>
           </a:p>
           <a:p>
@@ -10877,6 +10914,7 @@
               </a:defRPr>
             </a:pPr>
             <a:r>
+              <a:rPr dirty="0"/>
               <a:t>• Strategic sourcing &amp; commodity strategy</a:t>
             </a:r>
           </a:p>
@@ -10893,6 +10931,7 @@
               </a:defRPr>
             </a:pPr>
             <a:r>
+              <a:rPr dirty="0"/>
               <a:t>• Risk mitigation and supply continuity</a:t>
             </a:r>
           </a:p>
@@ -10909,6 +10948,7 @@
               </a:defRPr>
             </a:pPr>
             <a:r>
+              <a:rPr dirty="0"/>
               <a:t>• Supplier selection &amp; development</a:t>
             </a:r>
           </a:p>
@@ -12426,7 +12466,7 @@
             </a:pPr>
             <a:r>
               <a:rPr dirty="0"/>
-              <a:t>• $300M+ </a:t>
+              <a:t>• </a:t>
             </a:r>
             <a:r>
               <a:rPr lang="en-US" dirty="0" smtClean="0"/>
@@ -12437,9 +12477,14 @@
               <a:t>rocurement </a:t>
             </a:r>
             <a:r>
-              <a:rPr dirty="0"/>
+              <a:rPr dirty="0" smtClean="0"/>
               <a:t>spend</a:t>
             </a:r>
+            <a:r>
+              <a:rPr lang="en-US" dirty="0" smtClean="0"/>
+              <a:t> Management</a:t>
+            </a:r>
+            <a:endParaRPr dirty="0"/>
           </a:p>
           <a:p>
             <a:pPr>
@@ -12637,15 +12682,23 @@
             </a:pPr>
             <a:r>
               <a:rPr dirty="0"/>
-              <a:t>• 5%+ </a:t>
-            </a:r>
-            <a:r>
-              <a:rPr dirty="0" err="1"/>
+              <a:t>• </a:t>
+            </a:r>
+            <a:r>
+              <a:rPr lang="en-US" dirty="0" smtClean="0"/>
+              <a:t> </a:t>
+            </a:r>
+            <a:r>
+              <a:rPr dirty="0" err="1" smtClean="0"/>
               <a:t>YoY</a:t>
             </a:r>
             <a:r>
+              <a:rPr dirty="0" smtClean="0"/>
+              <a:t> </a:t>
+            </a:r>
+            <a:r>
               <a:rPr dirty="0"/>
-              <a:t> MATEX savings</a:t>
+              <a:t>MATEX savings</a:t>
             </a:r>
           </a:p>
           <a:p>

</xml_diff>